<commit_message>
Simplify results slide using starter evaluation terminology
</commit_message>
<xml_diff>
--- a/Magentic-RCA.pptx
+++ b/Magentic-RCA.pptx
@@ -2,14 +2,14 @@
 <file path=ppt/presentation.xml><?xml version="1.0" encoding="utf-8"?>
 <p:presentation xmlns:p="http://schemas.openxmlformats.org/presentationml/2006/main">
   <p:sldMasterIdLst>
-    <p:sldMasterId xmlns:r="http://schemas.openxmlformats.org/officeDocument/2006/relationships" id="2147483648" r:id="R43aca9133fa644e8"/>
+    <p:sldMasterId xmlns:r="http://schemas.openxmlformats.org/officeDocument/2006/relationships" id="2147483648" r:id="R8328fbde4e6041bb"/>
   </p:sldMasterIdLst>
   <p:notesMasterIdLst>
-    <p:notesMasterId xmlns:r="http://schemas.openxmlformats.org/officeDocument/2006/relationships" r:id="Rdcdce00d178a4321"/>
+    <p:notesMasterId xmlns:r="http://schemas.openxmlformats.org/officeDocument/2006/relationships" r:id="R4cd7c7c21f0341a3"/>
   </p:notesMasterIdLst>
   <p:sldIdLst>
-    <p:sldId xmlns:r="http://schemas.openxmlformats.org/officeDocument/2006/relationships" id="256" r:id="R0729e5275ff843af"/>
-    <p:sldId xmlns:r="http://schemas.openxmlformats.org/officeDocument/2006/relationships" id="257" r:id="R0efb8a40e2e04c69"/>
+    <p:sldId xmlns:r="http://schemas.openxmlformats.org/officeDocument/2006/relationships" id="256" r:id="R5a7d60b64d6f4d33"/>
+    <p:sldId xmlns:r="http://schemas.openxmlformats.org/officeDocument/2006/relationships" id="257" r:id="R3cc8ec0fd0d14939"/>
   </p:sldIdLst>
   <p:sldSz cx="12192000" cy="6858000"/>
   <p:notesSz cx="6858000" cy="9144000"/>
@@ -581,7 +581,7 @@
   </p:cSld>
   <p:clrMap bg1="lt1" tx1="dk1" bg2="lt2" tx2="dk2" accent1="accent1" accent2="accent2" accent3="accent3" accent4="accent4" accent5="accent5" accent6="accent6" hlink="hlink" folHlink="folHlink"/>
   <p:sldLayoutIdLst>
-    <p:sldLayoutId xmlns:r="http://schemas.openxmlformats.org/officeDocument/2006/relationships" id="2147483649" r:id="Re9953b10e21e4d2f"/>
+    <p:sldLayoutId xmlns:r="http://schemas.openxmlformats.org/officeDocument/2006/relationships" id="2147483649" r:id="R0f77ccd8b53a4194"/>
   </p:sldLayoutIdLst>
   <p:txStyles>
     <p:titleStyle>
@@ -1132,7 +1132,7 @@
           <p:cNvPr id="16" name="">
             <a:extLst xmlns:a="http://schemas.openxmlformats.org/drawingml/2006/main">
               <a:ext uri="{FF2B5EF4-FFF2-40B4-BE49-F238E27FC236}">
-                <a16:creationId xmlns:a16="http://schemas.microsoft.com/office/drawing/2014/main" id="{52CEC06F-4695-4B26-846A-EC39B06489A2}"/>
+                <a16:creationId xmlns:a16="http://schemas.microsoft.com/office/drawing/2014/main" id="{41C20B47-3B04-430A-89E4-249C59C2C33A}"/>
               </a:ext>
             </a:extLst>
           </p:cNvPr>
@@ -1189,7 +1189,7 @@
           <p:cNvPr id="2" name="">
             <a:extLst xmlns:a="http://schemas.openxmlformats.org/drawingml/2006/main">
               <a:ext uri="{FF2B5EF4-FFF2-40B4-BE49-F238E27FC236}">
-                <a16:creationId xmlns:a16="http://schemas.microsoft.com/office/drawing/2014/main" id="{89AE40A2-6B0C-41EE-BFC3-15FE6DCB7115}"/>
+                <a16:creationId xmlns:a16="http://schemas.microsoft.com/office/drawing/2014/main" id="{970C9A3E-F57A-4E3F-9BCB-164FCF1EB92E}"/>
               </a:ext>
             </a:extLst>
           </p:cNvPr>
@@ -1246,7 +1246,7 @@
           <p:cNvPr id="3" name="">
             <a:extLst xmlns:a="http://schemas.openxmlformats.org/drawingml/2006/main">
               <a:ext uri="{FF2B5EF4-FFF2-40B4-BE49-F238E27FC236}">
-                <a16:creationId xmlns:a16="http://schemas.microsoft.com/office/drawing/2014/main" id="{A3961D1A-E00D-491C-ACF5-558E7EDDA964}"/>
+                <a16:creationId xmlns:a16="http://schemas.microsoft.com/office/drawing/2014/main" id="{B8A7A04A-AFBC-4C40-A802-16EE816C313F}"/>
               </a:ext>
             </a:extLst>
           </p:cNvPr>
@@ -1303,7 +1303,7 @@
           <p:cNvPr id="4" name="">
             <a:extLst xmlns:a="http://schemas.openxmlformats.org/drawingml/2006/main">
               <a:ext uri="{FF2B5EF4-FFF2-40B4-BE49-F238E27FC236}">
-                <a16:creationId xmlns:a16="http://schemas.microsoft.com/office/drawing/2014/main" id="{DF734FC3-EC5F-49F5-8FDE-9AC4268BF260}"/>
+                <a16:creationId xmlns:a16="http://schemas.microsoft.com/office/drawing/2014/main" id="{7E9A2614-D37B-4429-A507-1F4D10647A34}"/>
               </a:ext>
             </a:extLst>
           </p:cNvPr>
@@ -1360,7 +1360,7 @@
           <p:cNvPr id="5" name="">
             <a:extLst xmlns:a="http://schemas.openxmlformats.org/drawingml/2006/main">
               <a:ext uri="{FF2B5EF4-FFF2-40B4-BE49-F238E27FC236}">
-                <a16:creationId xmlns:a16="http://schemas.microsoft.com/office/drawing/2014/main" id="{E65FCD1A-232E-46B6-8754-BDAE632A16EF}"/>
+                <a16:creationId xmlns:a16="http://schemas.microsoft.com/office/drawing/2014/main" id="{9517936C-7C05-4D16-B5FA-3788B3B8804F}"/>
               </a:ext>
             </a:extLst>
           </p:cNvPr>
@@ -1417,7 +1417,7 @@
           <p:cNvPr id="6" name="">
             <a:extLst xmlns:a="http://schemas.openxmlformats.org/drawingml/2006/main">
               <a:ext uri="{FF2B5EF4-FFF2-40B4-BE49-F238E27FC236}">
-                <a16:creationId xmlns:a16="http://schemas.microsoft.com/office/drawing/2014/main" id="{0FACCF60-F130-4737-9858-3BFC3989926E}"/>
+                <a16:creationId xmlns:a16="http://schemas.microsoft.com/office/drawing/2014/main" id="{8721FA8F-48A6-4370-8FEB-97663930BA22}"/>
               </a:ext>
             </a:extLst>
           </p:cNvPr>
@@ -1474,7 +1474,7 @@
           <p:cNvPr id="7" name="">
             <a:extLst xmlns:a="http://schemas.openxmlformats.org/drawingml/2006/main">
               <a:ext uri="{FF2B5EF4-FFF2-40B4-BE49-F238E27FC236}">
-                <a16:creationId xmlns:a16="http://schemas.microsoft.com/office/drawing/2014/main" id="{9D25FB98-3008-4BE7-86F7-E566EBB71D9E}"/>
+                <a16:creationId xmlns:a16="http://schemas.microsoft.com/office/drawing/2014/main" id="{83205EA6-EED9-40B5-9EAD-B28C69E9EF65}"/>
               </a:ext>
             </a:extLst>
           </p:cNvPr>
@@ -1531,7 +1531,7 @@
           <p:cNvPr id="8" name="">
             <a:extLst xmlns:a="http://schemas.openxmlformats.org/drawingml/2006/main">
               <a:ext uri="{FF2B5EF4-FFF2-40B4-BE49-F238E27FC236}">
-                <a16:creationId xmlns:a16="http://schemas.microsoft.com/office/drawing/2014/main" id="{428B7F25-A50E-4F92-8945-C0DA9E13C9F3}"/>
+                <a16:creationId xmlns:a16="http://schemas.microsoft.com/office/drawing/2014/main" id="{7C61A767-B42C-4E9F-9C34-3242645F33C9}"/>
               </a:ext>
             </a:extLst>
           </p:cNvPr>
@@ -1588,7 +1588,7 @@
           <p:cNvPr id="9" name="">
             <a:extLst xmlns:a="http://schemas.openxmlformats.org/drawingml/2006/main">
               <a:ext uri="{FF2B5EF4-FFF2-40B4-BE49-F238E27FC236}">
-                <a16:creationId xmlns:a16="http://schemas.microsoft.com/office/drawing/2014/main" id="{91329091-5BD8-4B45-BC07-5686CE4302D7}"/>
+                <a16:creationId xmlns:a16="http://schemas.microsoft.com/office/drawing/2014/main" id="{8DDC0F0F-96E7-432B-B38D-5F5796F7B0D0}"/>
               </a:ext>
             </a:extLst>
           </p:cNvPr>
@@ -1645,7 +1645,7 @@
           <p:cNvPr id="10" name="">
             <a:extLst xmlns:a="http://schemas.openxmlformats.org/drawingml/2006/main">
               <a:ext uri="{FF2B5EF4-FFF2-40B4-BE49-F238E27FC236}">
-                <a16:creationId xmlns:a16="http://schemas.microsoft.com/office/drawing/2014/main" id="{3A432FC3-EAA4-48B9-B325-B3A88AF2848C}"/>
+                <a16:creationId xmlns:a16="http://schemas.microsoft.com/office/drawing/2014/main" id="{89FED5C1-D47B-4896-A42B-BAE8DF15DE3E}"/>
               </a:ext>
             </a:extLst>
           </p:cNvPr>
@@ -1702,7 +1702,7 @@
           <p:cNvPr id="11" name="">
             <a:extLst xmlns:a="http://schemas.openxmlformats.org/drawingml/2006/main">
               <a:ext uri="{FF2B5EF4-FFF2-40B4-BE49-F238E27FC236}">
-                <a16:creationId xmlns:a16="http://schemas.microsoft.com/office/drawing/2014/main" id="{360BD854-DD06-4347-8737-FD63A97D3BE9}"/>
+                <a16:creationId xmlns:a16="http://schemas.microsoft.com/office/drawing/2014/main" id="{6F7EFDB9-ACE0-4877-9345-18B07309BAD0}"/>
               </a:ext>
             </a:extLst>
           </p:cNvPr>
@@ -1759,7 +1759,7 @@
           <p:cNvPr id="12" name="">
             <a:extLst xmlns:a="http://schemas.openxmlformats.org/drawingml/2006/main">
               <a:ext uri="{FF2B5EF4-FFF2-40B4-BE49-F238E27FC236}">
-                <a16:creationId xmlns:a16="http://schemas.microsoft.com/office/drawing/2014/main" id="{37BC1E9E-A60F-4C35-BE8F-70B07D673590}"/>
+                <a16:creationId xmlns:a16="http://schemas.microsoft.com/office/drawing/2014/main" id="{607C6F89-A077-4826-BA17-D82EBC66C137}"/>
               </a:ext>
             </a:extLst>
           </p:cNvPr>
@@ -1816,7 +1816,7 @@
           <p:cNvPr id="13" name="">
             <a:extLst xmlns:a="http://schemas.openxmlformats.org/drawingml/2006/main">
               <a:ext uri="{FF2B5EF4-FFF2-40B4-BE49-F238E27FC236}">
-                <a16:creationId xmlns:a16="http://schemas.microsoft.com/office/drawing/2014/main" id="{E61DFBB2-2E57-480E-B10F-977794644E80}"/>
+                <a16:creationId xmlns:a16="http://schemas.microsoft.com/office/drawing/2014/main" id="{54642042-D9A2-4DFC-AF72-8EE7A21FCDD5}"/>
               </a:ext>
             </a:extLst>
           </p:cNvPr>
@@ -1873,7 +1873,7 @@
           <p:cNvPr id="14" name="">
             <a:extLst xmlns:a="http://schemas.openxmlformats.org/drawingml/2006/main">
               <a:ext uri="{FF2B5EF4-FFF2-40B4-BE49-F238E27FC236}">
-                <a16:creationId xmlns:a16="http://schemas.microsoft.com/office/drawing/2014/main" id="{6B61D80C-6EFF-4212-9D61-2DCF81505BFD}"/>
+                <a16:creationId xmlns:a16="http://schemas.microsoft.com/office/drawing/2014/main" id="{1C6BE132-797F-4436-AFC3-40627C80AD79}"/>
               </a:ext>
             </a:extLst>
           </p:cNvPr>
@@ -1930,7 +1930,7 @@
           <p:cNvPr id="15" name="">
             <a:extLst xmlns:a="http://schemas.openxmlformats.org/drawingml/2006/main">
               <a:ext uri="{FF2B5EF4-FFF2-40B4-BE49-F238E27FC236}">
-                <a16:creationId xmlns:a16="http://schemas.microsoft.com/office/drawing/2014/main" id="{7B1BC676-5497-4273-98D3-AA777B96D782}"/>
+                <a16:creationId xmlns:a16="http://schemas.microsoft.com/office/drawing/2014/main" id="{DAF77334-3D3B-48D5-9DF2-A38513D5EC08}"/>
               </a:ext>
             </a:extLst>
           </p:cNvPr>
@@ -1985,7 +1985,7 @@
     </p:spTree>
     <p:extLst>
       <p:ext uri="{BB962C8B-B14F-4D97-AF65-F5344CB8AC3E}">
-        <p14:creationId xmlns:p14="http://schemas.microsoft.com/office/powerpoint/2010/main" val="462306766"/>
+        <p14:creationId xmlns:p14="http://schemas.microsoft.com/office/powerpoint/2010/main" val="976267283"/>
       </p:ext>
     </p:extLst>
   </p:cSld>
@@ -2016,7 +2016,7 @@
           <p:cNvPr id="6" name="">
             <a:extLst xmlns:a="http://schemas.openxmlformats.org/drawingml/2006/main">
               <a:ext uri="{FF2B5EF4-FFF2-40B4-BE49-F238E27FC236}">
-                <a16:creationId xmlns:a16="http://schemas.microsoft.com/office/drawing/2014/main" id="{E62CB054-8179-406F-8E9E-CFF66B8F8313}"/>
+                <a16:creationId xmlns:a16="http://schemas.microsoft.com/office/drawing/2014/main" id="{DCA4B627-24D8-44F2-8A8C-8720DAE9142F}"/>
               </a:ext>
             </a:extLst>
           </p:cNvPr>
@@ -2063,7 +2063,7 @@
                 <a:ea typeface="Helvetica Neue"/>
                 <a:cs typeface="Helvetica Neue"/>
               </a:rPr>
-              <a:t>Routed completed both investigations</a:t>
+              <a:t>Routed agent vs. single model</a:t>
             </a:r>
           </a:p>
         </p:txBody>
@@ -2073,7 +2073,7 @@
           <p:cNvPr id="2" name="">
             <a:extLst xmlns:a="http://schemas.openxmlformats.org/drawingml/2006/main">
               <a:ext uri="{FF2B5EF4-FFF2-40B4-BE49-F238E27FC236}">
-                <a16:creationId xmlns:a16="http://schemas.microsoft.com/office/drawing/2014/main" id="{4785B5A9-66A6-4FEC-9F9D-1150119CF0CF}"/>
+                <a16:creationId xmlns:a16="http://schemas.microsoft.com/office/drawing/2014/main" id="{E5DAFE24-D256-407D-A568-334C802B3BAD}"/>
               </a:ext>
             </a:extLst>
           </p:cNvPr>
@@ -2120,7 +2120,7 @@
                 <a:ea typeface="Helvetica Neue"/>
                 <a:cs typeface="Helvetica Neue"/>
               </a:rPr>
-              <a:t>2 development cases • 1 repeat per configuration • 5-minute case ceiling</a:t>
+              <a:t>2 development cases • one run each • up to 5 minutes per case</a:t>
             </a:r>
           </a:p>
         </p:txBody>
@@ -2133,18 +2133,18 @@
         </p:nvGraphicFramePr>
         <p:xfrm>
           <a:off xmlns:a="http://schemas.openxmlformats.org/drawingml/2006/main" x="609600" y="1819275"/>
-          <a:ext xmlns:a="http://schemas.openxmlformats.org/drawingml/2006/main" cx="10972800" cy="3133725"/>
+          <a:ext xmlns:a="http://schemas.openxmlformats.org/drawingml/2006/main" cx="10972800" cy="2714625"/>
         </p:xfrm>
         <a:graphic xmlns:a="http://schemas.openxmlformats.org/drawingml/2006/main">
           <a:graphicData uri="http://schemas.openxmlformats.org/drawingml/2006/table">
             <a:tbl>
               <a:tblPr/>
               <a:tblGrid>
-                <a:gridCol w="5486400"/>
-                <a:gridCol w="2743200"/>
-                <a:gridCol w="2743200"/>
+                <a:gridCol w="4591050"/>
+                <a:gridCol w="3048000"/>
+                <a:gridCol w="3333750"/>
               </a:tblGrid>
-              <a:tr h="447675">
+              <a:tr h="542925">
                 <a:tc>
                   <a:txBody>
                     <a:bodyPr/>
@@ -2183,7 +2183,7 @@
                           <a:ea typeface="Helvetica Neue"/>
                           <a:cs typeface="Helvetica Neue"/>
                         </a:rPr>
-                        <a:t>Routed GLM</a:t>
+                        <a:t>Routed agent</a:t>
                       </a:r>
                     </a:p>
                   </a:txBody>
@@ -2207,7 +2207,7 @@
                           <a:ea typeface="Helvetica Neue"/>
                           <a:cs typeface="Helvetica Neue"/>
                         </a:rPr>
-                        <a:t>Fixed GLM-5.2</a:t>
+                        <a:t>Single model (GLM-5.2)</a:t>
                       </a:r>
                     </a:p>
                   </a:txBody>
@@ -2218,7 +2218,7 @@
                   </a:tcPr>
                 </a:tc>
               </a:tr>
-              <a:tr h="447675">
+              <a:tr h="542925">
                 <a:tc>
                   <a:txBody>
                     <a:bodyPr/>
@@ -2233,7 +2233,7 @@
                           <a:ea typeface="Helvetica Neue"/>
                           <a:cs typeface="Helvetica Neue"/>
                         </a:rPr>
-                        <a:t>Completed investigations</a:t>
+                        <a:t>Accuracy (strict)</a:t>
                       </a:r>
                     </a:p>
                   </a:txBody>
@@ -2257,7 +2257,7 @@
                           <a:ea typeface="Helvetica Neue"/>
                           <a:cs typeface="Helvetica Neue"/>
                         </a:rPr>
-                        <a:t>2 / 2</a:t>
+                        <a:t>50%</a:t>
                       </a:r>
                     </a:p>
                   </a:txBody>
@@ -2281,7 +2281,7 @@
                           <a:ea typeface="Helvetica Neue"/>
                           <a:cs typeface="Helvetica Neue"/>
                         </a:rPr>
-                        <a:t>0 / 2</a:t>
+                        <a:t>50%</a:t>
                       </a:r>
                     </a:p>
                   </a:txBody>
@@ -2292,7 +2292,7 @@
                   </a:tcPr>
                 </a:tc>
               </a:tr>
-              <a:tr h="447675">
+              <a:tr h="542925">
                 <a:tc>
                   <a:txBody>
                     <a:bodyPr/>
@@ -2307,7 +2307,7 @@
                           <a:ea typeface="Helvetica Neue"/>
                           <a:cs typeface="Helvetica Neue"/>
                         </a:rPr>
-                        <a:t>Strict accuracy</a:t>
+                        <a:t>Accuracy (partial credit)</a:t>
                       </a:r>
                     </a:p>
                   </a:txBody>
@@ -2331,7 +2331,7 @@
                           <a:ea typeface="Helvetica Neue"/>
                           <a:cs typeface="Helvetica Neue"/>
                         </a:rPr>
-                        <a:t>50%</a:t>
+                        <a:t>75%</a:t>
                       </a:r>
                     </a:p>
                   </a:txBody>
@@ -2366,7 +2366,7 @@
                   </a:tcPr>
                 </a:tc>
               </a:tr>
-              <a:tr h="447675">
+              <a:tr h="542925">
                 <a:tc>
                   <a:txBody>
                     <a:bodyPr/>
@@ -2381,155 +2381,7 @@
                           <a:ea typeface="Helvetica Neue"/>
                           <a:cs typeface="Helvetica Neue"/>
                         </a:rPr>
-                        <a:t>Partial score</a:t>
-                      </a:r>
-                    </a:p>
-                  </a:txBody>
-                  <a:tcPr marL="91440" marR="91440" marT="45720" marB="45720">
-                    <a:solidFill>
-                      <a:srgbClr val="FFFFFF"/>
-                    </a:solidFill>
-                  </a:tcPr>
-                </a:tc>
-                <a:tc>
-                  <a:txBody>
-                    <a:bodyPr/>
-                    <a:lstStyle/>
-                    <a:p>
-                      <a:r>
-                        <a:rPr sz="1800" b="1">
-                          <a:solidFill>
-                            <a:srgbClr val="087F78"/>
-                          </a:solidFill>
-                          <a:latin typeface="Helvetica Neue"/>
-                          <a:ea typeface="Helvetica Neue"/>
-                          <a:cs typeface="Helvetica Neue"/>
-                        </a:rPr>
-                        <a:t>75%</a:t>
-                      </a:r>
-                    </a:p>
-                  </a:txBody>
-                  <a:tcPr marL="91440" marR="91440" marT="45720" marB="45720">
-                    <a:solidFill>
-                      <a:srgbClr val="FFFFFF"/>
-                    </a:solidFill>
-                  </a:tcPr>
-                </a:tc>
-                <a:tc>
-                  <a:txBody>
-                    <a:bodyPr/>
-                    <a:lstStyle/>
-                    <a:p>
-                      <a:r>
-                        <a:rPr sz="1800" b="0">
-                          <a:solidFill>
-                            <a:srgbClr val="132F3C"/>
-                          </a:solidFill>
-                          <a:latin typeface="Helvetica Neue"/>
-                          <a:ea typeface="Helvetica Neue"/>
-                          <a:cs typeface="Helvetica Neue"/>
-                        </a:rPr>
-                        <a:t>50%</a:t>
-                      </a:r>
-                    </a:p>
-                  </a:txBody>
-                  <a:tcPr marL="91440" marR="91440" marT="45720" marB="45720">
-                    <a:solidFill>
-                      <a:srgbClr val="FFFFFF"/>
-                    </a:solidFill>
-                  </a:tcPr>
-                </a:tc>
-              </a:tr>
-              <a:tr h="447675">
-                <a:tc>
-                  <a:txBody>
-                    <a:bodyPr/>
-                    <a:lstStyle/>
-                    <a:p>
-                      <a:r>
-                        <a:rPr sz="1800" b="0">
-                          <a:solidFill>
-                            <a:srgbClr val="132F3C"/>
-                          </a:solidFill>
-                          <a:latin typeface="Helvetica Neue"/>
-                          <a:ea typeface="Helvetica Neue"/>
-                          <a:cs typeface="Helvetica Neue"/>
-                        </a:rPr>
-                        <a:t>Prolog checks: passed / run</a:t>
-                      </a:r>
-                    </a:p>
-                  </a:txBody>
-                  <a:tcPr marL="91440" marR="91440" marT="45720" marB="45720">
-                    <a:solidFill>
-                      <a:srgbClr val="EDF2F0"/>
-                    </a:solidFill>
-                  </a:tcPr>
-                </a:tc>
-                <a:tc>
-                  <a:txBody>
-                    <a:bodyPr/>
-                    <a:lstStyle/>
-                    <a:p>
-                      <a:r>
-                        <a:rPr sz="1800" b="1">
-                          <a:solidFill>
-                            <a:srgbClr val="087F78"/>
-                          </a:solidFill>
-                          <a:latin typeface="Helvetica Neue"/>
-                          <a:ea typeface="Helvetica Neue"/>
-                          <a:cs typeface="Helvetica Neue"/>
-                        </a:rPr>
-                        <a:t>7 / 7</a:t>
-                      </a:r>
-                    </a:p>
-                  </a:txBody>
-                  <a:tcPr marL="91440" marR="91440" marT="45720" marB="45720">
-                    <a:solidFill>
-                      <a:srgbClr val="EDF2F0"/>
-                    </a:solidFill>
-                  </a:tcPr>
-                </a:tc>
-                <a:tc>
-                  <a:txBody>
-                    <a:bodyPr/>
-                    <a:lstStyle/>
-                    <a:p>
-                      <a:r>
-                        <a:rPr sz="1800" b="0">
-                          <a:solidFill>
-                            <a:srgbClr val="132F3C"/>
-                          </a:solidFill>
-                          <a:latin typeface="Helvetica Neue"/>
-                          <a:ea typeface="Helvetica Neue"/>
-                          <a:cs typeface="Helvetica Neue"/>
-                        </a:rPr>
-                        <a:t>11 / 11</a:t>
-                      </a:r>
-                    </a:p>
-                  </a:txBody>
-                  <a:tcPr marL="91440" marR="91440" marT="45720" marB="45720">
-                    <a:solidFill>
-                      <a:srgbClr val="EDF2F0"/>
-                    </a:solidFill>
-                  </a:tcPr>
-                </a:tc>
-              </a:tr>
-              <a:tr h="447675">
-                <a:tc>
-                  <a:txBody>
-                    <a:bodyPr/>
-                    <a:lstStyle/>
-                    <a:p>
-                      <a:r>
-                        <a:rPr sz="1800" b="0">
-                          <a:solidFill>
-                            <a:srgbClr val="132F3C"/>
-                          </a:solidFill>
-                          <a:latin typeface="Helvetica Neue"/>
-                          <a:ea typeface="Helvetica Neue"/>
-                          <a:cs typeface="Helvetica Neue"/>
-                        </a:rPr>
-                        <a:t>Mean cost / case</a:t>
+                        <a:t>Dollars per case</a:t>
                       </a:r>
                     </a:p>
                   </a:txBody>
@@ -2588,7 +2440,7 @@
                   </a:tcPr>
                 </a:tc>
               </a:tr>
-              <a:tr h="447675">
+              <a:tr h="542925">
                 <a:tc>
                   <a:txBody>
                     <a:bodyPr/>
@@ -2603,7 +2455,7 @@
                           <a:ea typeface="Helvetica Neue"/>
                           <a:cs typeface="Helvetica Neue"/>
                         </a:rPr>
-                        <a:t>Mean time / case</a:t>
+                        <a:t>Time per case</a:t>
                       </a:r>
                     </a:p>
                   </a:txBody>
@@ -2671,7 +2523,7 @@
           <p:cNvPr id="4" name="">
             <a:extLst xmlns:a="http://schemas.openxmlformats.org/drawingml/2006/main">
               <a:ext uri="{FF2B5EF4-FFF2-40B4-BE49-F238E27FC236}">
-                <a16:creationId xmlns:a16="http://schemas.microsoft.com/office/drawing/2014/main" id="{80D263FB-FB0F-459F-AABE-636D5AEAD4D7}"/>
+                <a16:creationId xmlns:a16="http://schemas.microsoft.com/office/drawing/2014/main" id="{017434A5-6615-4ED8-A21C-DA0049E2489B}"/>
               </a:ext>
             </a:extLst>
           </p:cNvPr>
@@ -2682,8 +2534,8 @@
         </p:nvSpPr>
         <p:spPr>
           <a:xfrm xmlns:a="http://schemas.openxmlformats.org/drawingml/2006/main">
-            <a:off x="609600" y="5229225"/>
-            <a:ext cx="10972800" cy="381000"/>
+            <a:off x="609600" y="4876800"/>
+            <a:ext cx="10972800" cy="762000"/>
           </a:xfrm>
           <a:prstGeom xmlns:a="http://schemas.openxmlformats.org/drawingml/2006/main" prst="rect">
             <a:avLst/>
@@ -2700,7 +2552,7 @@
           <a:lstStyle xmlns:a="http://schemas.openxmlformats.org/drawingml/2006/main"/>
           <a:p xmlns:a="http://schemas.openxmlformats.org/drawingml/2006/main">
             <a:pPr>
-              <a:defRPr sz="1875" b="1">
+              <a:defRPr sz="2025" b="1">
                 <a:solidFill>
                   <a:srgbClr val="132F3C"/>
                 </a:solidFill>
@@ -2710,7 +2562,7 @@
               </a:defRPr>
             </a:pPr>
             <a:r>
-              <a:rPr sz="1875" b="1">
+              <a:rPr sz="2025" b="1">
                 <a:solidFill>
                   <a:srgbClr val="132F3C"/>
                 </a:solidFill>
@@ -2718,7 +2570,7 @@
                 <a:ea typeface="Helvetica Neue"/>
                 <a:cs typeface="Helvetica Neue"/>
               </a:rPr>
-              <a:t>Fixed hit 25-second request timeouts and fell back on both cases.</a:t>
+              <a:t>The routed agent finished both cases. The single model timed out and used backup answers.</a:t>
             </a:r>
           </a:p>
         </p:txBody>
@@ -2728,7 +2580,7 @@
           <p:cNvPr id="5" name="">
             <a:extLst xmlns:a="http://schemas.openxmlformats.org/drawingml/2006/main">
               <a:ext uri="{FF2B5EF4-FFF2-40B4-BE49-F238E27FC236}">
-                <a16:creationId xmlns:a16="http://schemas.microsoft.com/office/drawing/2014/main" id="{914CE864-5E6A-4612-A145-F1C7A03D6C33}"/>
+                <a16:creationId xmlns:a16="http://schemas.microsoft.com/office/drawing/2014/main" id="{3AD55B17-37B0-4157-AA90-F1195E597D98}"/>
               </a:ext>
             </a:extLst>
           </p:cNvPr>
@@ -2739,8 +2591,8 @@
         </p:nvSpPr>
         <p:spPr>
           <a:xfrm xmlns:a="http://schemas.openxmlformats.org/drawingml/2006/main">
-            <a:off x="609600" y="5705475"/>
-            <a:ext cx="10972800" cy="685800"/>
+            <a:off x="609600" y="5848350"/>
+            <a:ext cx="10972800" cy="619125"/>
           </a:xfrm>
           <a:prstGeom xmlns:a="http://schemas.openxmlformats.org/drawingml/2006/main" prst="rect">
             <a:avLst/>
@@ -2757,7 +2609,7 @@
           <a:lstStyle xmlns:a="http://schemas.openxmlformats.org/drawingml/2006/main"/>
           <a:p xmlns:a="http://schemas.openxmlformats.org/drawingml/2006/main">
             <a:pPr>
-              <a:defRPr sz="1800" b="0">
+              <a:defRPr sz="1725" b="0">
                 <a:solidFill>
                   <a:srgbClr val="53636D"/>
                 </a:solidFill>
@@ -2767,7 +2619,7 @@
               </a:defRPr>
             </a:pPr>
             <a:r>
-              <a:rPr sz="1800" b="0">
+              <a:rPr sz="1725" b="0">
                 <a:solidFill>
                   <a:srgbClr val="53636D"/>
                 </a:solidFill>
@@ -2775,7 +2627,7 @@
                 <a:ea typeface="Helvetica Neue"/>
                 <a:cs typeface="Helvetica Neue"/>
               </a:rPr>
-              <a:t>Small sample; no generalization claim. One routed diagnosis had the right component but the wrong failure reason.</a:t>
+              <a:t>Only two cases tested. Single-model cost and time reflect early stops, not greater efficiency.</a:t>
             </a:r>
           </a:p>
         </p:txBody>
@@ -2783,7 +2635,7 @@
     </p:spTree>
     <p:extLst>
       <p:ext uri="{BB962C8B-B14F-4D97-AF65-F5344CB8AC3E}">
-        <p14:creationId xmlns:p14="http://schemas.microsoft.com/office/powerpoint/2010/main" val="348530994"/>
+        <p14:creationId xmlns:p14="http://schemas.microsoft.com/office/powerpoint/2010/main" val="1308148683"/>
       </p:ext>
     </p:extLst>
   </p:cSld>

</xml_diff>